<commit_message>
Changes to be committed: 	modified:   Soutenance - MLOps.pptx
Changes not staged for commit:
	deleted:    Soutenance - MLOps.pptx
</commit_message>
<xml_diff>
--- a/Soutenance - MLOps.pptx
+++ b/Soutenance - MLOps.pptx
@@ -5,7 +5,7 @@
     <p:sldMasterId id="2147483648" r:id="rId1"/>
   </p:sldMasterIdLst>
   <p:notesMasterIdLst>
-    <p:notesMasterId r:id="rId13"/>
+    <p:notesMasterId r:id="rId14"/>
   </p:notesMasterIdLst>
   <p:sldIdLst>
     <p:sldId id="256" r:id="rId2"/>
@@ -18,7 +18,8 @@
     <p:sldId id="308" r:id="rId9"/>
     <p:sldId id="309" r:id="rId10"/>
     <p:sldId id="307" r:id="rId11"/>
-    <p:sldId id="268" r:id="rId12"/>
+    <p:sldId id="310" r:id="rId12"/>
+    <p:sldId id="268" r:id="rId13"/>
   </p:sldIdLst>
   <p:sldSz cx="24384000" cy="13716000"/>
   <p:notesSz cx="6858000" cy="9144000"/>
@@ -335,6 +336,7 @@
             <p14:sldId id="308"/>
             <p14:sldId id="309"/>
             <p14:sldId id="307"/>
+            <p14:sldId id="310"/>
             <p14:sldId id="268"/>
           </p14:sldIdLst>
         </p14:section>
@@ -600,683 +602,7 @@
           <a:bodyPr/>
           <a:lstStyle/>
           <a:p>
-            <a:r>
-              <a:rPr lang="en-US">
-                <a:latin typeface="Calibri"/>
-                <a:ea typeface="Calibri"/>
-                <a:cs typeface="Calibri"/>
-              </a:rPr>
-              <a:t>Yassine – Introduction</a:t>
-            </a:r>
-          </a:p>
-          <a:p>
-            <a:endParaRPr lang="en-US">
-              <a:solidFill>
-                <a:srgbClr val="000000"/>
-              </a:solidFill>
-              <a:latin typeface="Calibri"/>
-              <a:ea typeface="Calibri"/>
-              <a:cs typeface="Calibri"/>
-            </a:endParaRPr>
-          </a:p>
-          <a:p>
-            <a:pPr algn="l"/>
-            <a:r>
-              <a:rPr lang="en-US">
-                <a:solidFill>
-                  <a:srgbClr val="000000"/>
-                </a:solidFill>
-              </a:rPr>
-              <a:t>La </a:t>
-            </a:r>
-            <a:r>
-              <a:rPr lang="en-US" err="1">
-                <a:solidFill>
-                  <a:srgbClr val="000000"/>
-                </a:solidFill>
-              </a:rPr>
-              <a:t>présentation</a:t>
-            </a:r>
-            <a:r>
-              <a:rPr lang="en-US">
-                <a:solidFill>
-                  <a:srgbClr val="000000"/>
-                </a:solidFill>
-              </a:rPr>
-              <a:t> </a:t>
-            </a:r>
-            <a:r>
-              <a:rPr lang="en-US" err="1">
-                <a:solidFill>
-                  <a:srgbClr val="000000"/>
-                </a:solidFill>
-              </a:rPr>
-              <a:t>devra</a:t>
-            </a:r>
-            <a:r>
-              <a:rPr lang="en-US">
-                <a:solidFill>
-                  <a:srgbClr val="000000"/>
-                </a:solidFill>
-              </a:rPr>
-              <a:t> démontrer que </a:t>
-            </a:r>
-            <a:endParaRPr lang="en-US"/>
-          </a:p>
-          <a:p>
-            <a:pPr algn="l"/>
-            <a:r>
-              <a:rPr lang="en-US">
-                <a:solidFill>
-                  <a:srgbClr val="000000"/>
-                </a:solidFill>
-              </a:rPr>
-              <a:t>- (1) vous </a:t>
-            </a:r>
-            <a:r>
-              <a:rPr lang="en-US" err="1">
-                <a:solidFill>
-                  <a:srgbClr val="000000"/>
-                </a:solidFill>
-              </a:rPr>
-              <a:t>vous</a:t>
-            </a:r>
-            <a:r>
-              <a:rPr lang="en-US">
-                <a:solidFill>
-                  <a:srgbClr val="000000"/>
-                </a:solidFill>
-              </a:rPr>
-              <a:t> </a:t>
-            </a:r>
-            <a:r>
-              <a:rPr lang="en-US" err="1">
-                <a:solidFill>
-                  <a:srgbClr val="000000"/>
-                </a:solidFill>
-              </a:rPr>
-              <a:t>êtes</a:t>
-            </a:r>
-            <a:r>
-              <a:rPr lang="en-US">
-                <a:solidFill>
-                  <a:srgbClr val="000000"/>
-                </a:solidFill>
-              </a:rPr>
-              <a:t> bien </a:t>
-            </a:r>
-            <a:r>
-              <a:rPr lang="en-US" err="1">
-                <a:solidFill>
-                  <a:srgbClr val="000000"/>
-                </a:solidFill>
-              </a:rPr>
-              <a:t>approprié</a:t>
-            </a:r>
-            <a:r>
-              <a:rPr lang="en-US">
-                <a:solidFill>
-                  <a:srgbClr val="000000"/>
-                </a:solidFill>
-              </a:rPr>
-              <a:t> le </a:t>
-            </a:r>
-            <a:r>
-              <a:rPr lang="en-US" err="1">
-                <a:solidFill>
-                  <a:srgbClr val="000000"/>
-                </a:solidFill>
-              </a:rPr>
-              <a:t>projet</a:t>
-            </a:r>
-            <a:r>
-              <a:rPr lang="en-US">
-                <a:solidFill>
-                  <a:srgbClr val="000000"/>
-                </a:solidFill>
-              </a:rPr>
-              <a:t> (</a:t>
-            </a:r>
-            <a:r>
-              <a:rPr lang="en-US" err="1">
-                <a:solidFill>
-                  <a:srgbClr val="000000"/>
-                </a:solidFill>
-              </a:rPr>
-              <a:t>contexte</a:t>
-            </a:r>
-            <a:r>
-              <a:rPr lang="en-US">
-                <a:solidFill>
-                  <a:srgbClr val="000000"/>
-                </a:solidFill>
-              </a:rPr>
-              <a:t>, </a:t>
-            </a:r>
-            <a:r>
-              <a:rPr lang="en-US" err="1">
-                <a:solidFill>
-                  <a:srgbClr val="000000"/>
-                </a:solidFill>
-              </a:rPr>
-              <a:t>problématique</a:t>
-            </a:r>
-            <a:r>
-              <a:rPr lang="en-US">
-                <a:solidFill>
-                  <a:srgbClr val="000000"/>
-                </a:solidFill>
-              </a:rPr>
-              <a:t>, identification des </a:t>
-            </a:r>
-            <a:r>
-              <a:rPr lang="en-US" err="1">
-                <a:solidFill>
-                  <a:srgbClr val="000000"/>
-                </a:solidFill>
-              </a:rPr>
-              <a:t>verrous</a:t>
-            </a:r>
-            <a:r>
-              <a:rPr lang="en-US">
-                <a:solidFill>
-                  <a:srgbClr val="000000"/>
-                </a:solidFill>
-              </a:rPr>
-              <a:t> </a:t>
-            </a:r>
-            <a:r>
-              <a:rPr lang="en-US" err="1">
-                <a:solidFill>
-                  <a:srgbClr val="000000"/>
-                </a:solidFill>
-              </a:rPr>
-              <a:t>scientifiques</a:t>
-            </a:r>
-            <a:r>
-              <a:rPr lang="en-US">
-                <a:solidFill>
-                  <a:srgbClr val="000000"/>
-                </a:solidFill>
-              </a:rPr>
-              <a:t>) </a:t>
-            </a:r>
-            <a:endParaRPr lang="en-US"/>
-          </a:p>
-          <a:p>
-            <a:pPr algn="l"/>
-            <a:r>
-              <a:rPr lang="en-US">
-                <a:solidFill>
-                  <a:srgbClr val="000000"/>
-                </a:solidFill>
-              </a:rPr>
-              <a:t>- (2) vous </a:t>
-            </a:r>
-            <a:r>
-              <a:rPr lang="en-US" err="1">
-                <a:solidFill>
-                  <a:srgbClr val="000000"/>
-                </a:solidFill>
-              </a:rPr>
-              <a:t>avez</a:t>
-            </a:r>
-            <a:r>
-              <a:rPr lang="en-US">
-                <a:solidFill>
-                  <a:srgbClr val="000000"/>
-                </a:solidFill>
-              </a:rPr>
-              <a:t> </a:t>
-            </a:r>
-            <a:r>
-              <a:rPr lang="en-US" err="1">
-                <a:solidFill>
-                  <a:srgbClr val="000000"/>
-                </a:solidFill>
-              </a:rPr>
-              <a:t>amorcé</a:t>
-            </a:r>
-            <a:r>
-              <a:rPr lang="en-US">
-                <a:solidFill>
-                  <a:srgbClr val="000000"/>
-                </a:solidFill>
-              </a:rPr>
-              <a:t> le travail (par </a:t>
-            </a:r>
-            <a:r>
-              <a:rPr lang="en-US" err="1">
-                <a:solidFill>
-                  <a:srgbClr val="000000"/>
-                </a:solidFill>
-              </a:rPr>
-              <a:t>exemple</a:t>
-            </a:r>
-            <a:r>
-              <a:rPr lang="en-US">
-                <a:solidFill>
-                  <a:srgbClr val="000000"/>
-                </a:solidFill>
-              </a:rPr>
-              <a:t> </a:t>
-            </a:r>
-            <a:r>
-              <a:rPr lang="en-US" err="1">
-                <a:solidFill>
-                  <a:srgbClr val="000000"/>
-                </a:solidFill>
-              </a:rPr>
-              <a:t>prise</a:t>
-            </a:r>
-            <a:r>
-              <a:rPr lang="en-US">
-                <a:solidFill>
-                  <a:srgbClr val="000000"/>
-                </a:solidFill>
-              </a:rPr>
-              <a:t> </a:t>
-            </a:r>
-            <a:r>
-              <a:rPr lang="en-US" err="1">
-                <a:solidFill>
-                  <a:srgbClr val="000000"/>
-                </a:solidFill>
-              </a:rPr>
-              <a:t>en</a:t>
-            </a:r>
-            <a:r>
-              <a:rPr lang="en-US">
-                <a:solidFill>
-                  <a:srgbClr val="000000"/>
-                </a:solidFill>
-              </a:rPr>
-              <a:t> main des données) et </a:t>
-            </a:r>
-            <a:r>
-              <a:rPr lang="en-US" err="1">
-                <a:solidFill>
-                  <a:srgbClr val="000000"/>
-                </a:solidFill>
-              </a:rPr>
-              <a:t>cerné</a:t>
-            </a:r>
-            <a:r>
-              <a:rPr lang="en-US">
-                <a:solidFill>
-                  <a:srgbClr val="000000"/>
-                </a:solidFill>
-              </a:rPr>
-              <a:t> les </a:t>
-            </a:r>
-            <a:r>
-              <a:rPr lang="en-US" err="1">
-                <a:solidFill>
-                  <a:srgbClr val="000000"/>
-                </a:solidFill>
-              </a:rPr>
-              <a:t>pistes</a:t>
-            </a:r>
-            <a:r>
-              <a:rPr lang="en-US">
-                <a:solidFill>
-                  <a:srgbClr val="000000"/>
-                </a:solidFill>
-              </a:rPr>
-              <a:t> à </a:t>
-            </a:r>
-            <a:r>
-              <a:rPr lang="en-US" err="1">
-                <a:solidFill>
-                  <a:srgbClr val="000000"/>
-                </a:solidFill>
-              </a:rPr>
-              <a:t>implémenter</a:t>
-            </a:r>
-            <a:r>
-              <a:rPr lang="en-US">
-                <a:solidFill>
-                  <a:srgbClr val="000000"/>
-                </a:solidFill>
-              </a:rPr>
-              <a:t> (</a:t>
-            </a:r>
-            <a:r>
-              <a:rPr lang="en-US" err="1">
-                <a:solidFill>
-                  <a:srgbClr val="000000"/>
-                </a:solidFill>
-              </a:rPr>
-              <a:t>bibliographie</a:t>
-            </a:r>
-            <a:r>
-              <a:rPr lang="en-US">
-                <a:solidFill>
-                  <a:srgbClr val="000000"/>
-                </a:solidFill>
-              </a:rPr>
-              <a:t>).</a:t>
-            </a:r>
-            <a:endParaRPr lang="en-US"/>
-          </a:p>
-          <a:p>
-            <a:pPr algn="l"/>
-            <a:r>
-              <a:rPr lang="en-US">
-                <a:solidFill>
-                  <a:srgbClr val="000000"/>
-                </a:solidFill>
-              </a:rPr>
-              <a:t>- (3) vous </a:t>
-            </a:r>
-            <a:r>
-              <a:rPr lang="en-US" err="1">
-                <a:solidFill>
-                  <a:srgbClr val="000000"/>
-                </a:solidFill>
-              </a:rPr>
-              <a:t>avez</a:t>
-            </a:r>
-            <a:r>
-              <a:rPr lang="en-US">
-                <a:solidFill>
-                  <a:srgbClr val="000000"/>
-                </a:solidFill>
-              </a:rPr>
-              <a:t> </a:t>
-            </a:r>
-            <a:r>
-              <a:rPr lang="en-US" err="1">
-                <a:solidFill>
-                  <a:srgbClr val="000000"/>
-                </a:solidFill>
-              </a:rPr>
-              <a:t>réfléchi</a:t>
-            </a:r>
-            <a:r>
-              <a:rPr lang="en-US">
-                <a:solidFill>
-                  <a:srgbClr val="000000"/>
-                </a:solidFill>
-              </a:rPr>
-              <a:t> à </a:t>
-            </a:r>
-            <a:r>
-              <a:rPr lang="en-US" err="1">
-                <a:solidFill>
-                  <a:srgbClr val="000000"/>
-                </a:solidFill>
-              </a:rPr>
-              <a:t>l’organisation</a:t>
-            </a:r>
-            <a:r>
-              <a:rPr lang="en-US">
-                <a:solidFill>
-                  <a:srgbClr val="000000"/>
-                </a:solidFill>
-              </a:rPr>
-              <a:t> du travail à </a:t>
-            </a:r>
-            <a:r>
-              <a:rPr lang="en-US" err="1">
-                <a:solidFill>
-                  <a:srgbClr val="000000"/>
-                </a:solidFill>
-              </a:rPr>
-              <a:t>venir</a:t>
-            </a:r>
-            <a:r>
-              <a:rPr lang="en-US">
-                <a:solidFill>
-                  <a:srgbClr val="000000"/>
-                </a:solidFill>
-              </a:rPr>
-              <a:t> (</a:t>
-            </a:r>
-            <a:r>
-              <a:rPr lang="en-US" err="1">
-                <a:solidFill>
-                  <a:srgbClr val="000000"/>
-                </a:solidFill>
-              </a:rPr>
-              <a:t>exemple</a:t>
-            </a:r>
-            <a:r>
-              <a:rPr lang="en-US">
-                <a:solidFill>
-                  <a:srgbClr val="000000"/>
-                </a:solidFill>
-              </a:rPr>
-              <a:t> </a:t>
-            </a:r>
-            <a:r>
-              <a:rPr lang="en-US" err="1">
-                <a:solidFill>
-                  <a:srgbClr val="000000"/>
-                </a:solidFill>
-              </a:rPr>
-              <a:t>diagramme</a:t>
-            </a:r>
-            <a:r>
-              <a:rPr lang="en-US">
-                <a:solidFill>
-                  <a:srgbClr val="000000"/>
-                </a:solidFill>
-              </a:rPr>
-              <a:t> de Gant </a:t>
-            </a:r>
-            <a:r>
-              <a:rPr lang="en-US" err="1">
-                <a:solidFill>
-                  <a:srgbClr val="000000"/>
-                </a:solidFill>
-              </a:rPr>
-              <a:t>ou</a:t>
-            </a:r>
-            <a:r>
-              <a:rPr lang="en-US">
-                <a:solidFill>
-                  <a:srgbClr val="000000"/>
-                </a:solidFill>
-              </a:rPr>
-              <a:t> </a:t>
-            </a:r>
-            <a:r>
-              <a:rPr lang="en-US" err="1">
-                <a:solidFill>
-                  <a:srgbClr val="000000"/>
-                </a:solidFill>
-              </a:rPr>
-              <a:t>autre</a:t>
-            </a:r>
-            <a:r>
-              <a:rPr lang="en-US">
-                <a:solidFill>
-                  <a:srgbClr val="000000"/>
-                </a:solidFill>
-              </a:rPr>
-              <a:t>). </a:t>
-            </a:r>
-            <a:endParaRPr lang="en-US"/>
-          </a:p>
-          <a:p>
-            <a:pPr algn="l"/>
-            <a:r>
-              <a:rPr lang="en-US">
-                <a:solidFill>
-                  <a:srgbClr val="000000"/>
-                </a:solidFill>
-              </a:rPr>
-              <a:t> </a:t>
-            </a:r>
-            <a:endParaRPr lang="en-US"/>
-          </a:p>
-          <a:p>
-            <a:pPr algn="l"/>
-            <a:r>
-              <a:rPr lang="en-US">
-                <a:solidFill>
-                  <a:srgbClr val="000000"/>
-                </a:solidFill>
-              </a:rPr>
-              <a:t>P2 : Vous présenterez le contexte, les enjeux, l'état de l'art, les objectifs et les indicateurs associés. Vous préciserez les moyens humains et techniques ainsi que le planning des cinq mois en anticipant les difficultés et leurs solutions.</a:t>
-            </a:r>
-            <a:endParaRPr lang="en-US"/>
-          </a:p>
-          <a:p>
-            <a:pPr algn="l"/>
-            <a:r>
-              <a:rPr lang="en-US">
-                <a:solidFill>
-                  <a:srgbClr val="000000"/>
-                </a:solidFill>
-              </a:rPr>
-              <a:t> </a:t>
-            </a:r>
-            <a:endParaRPr lang="en-US"/>
-          </a:p>
-          <a:p>
-            <a:pPr algn="l"/>
-            <a:r>
-              <a:rPr lang="en-US">
-                <a:solidFill>
-                  <a:srgbClr val="000000"/>
-                </a:solidFill>
-              </a:rPr>
-              <a:t>Plan: </a:t>
-            </a:r>
-            <a:endParaRPr lang="en-US"/>
-          </a:p>
-          <a:p>
-            <a:pPr algn="l"/>
-            <a:r>
-              <a:rPr lang="en-US">
-                <a:solidFill>
-                  <a:srgbClr val="000000"/>
-                </a:solidFill>
-              </a:rPr>
-              <a:t>Yassine: Intro, Data, Roadmap </a:t>
-            </a:r>
-            <a:endParaRPr lang="en-US"/>
-          </a:p>
-          <a:p>
-            <a:pPr algn="l"/>
-            <a:r>
-              <a:rPr lang="en-US">
-                <a:solidFill>
-                  <a:srgbClr val="000000"/>
-                </a:solidFill>
-              </a:rPr>
-              <a:t>Andrew: </a:t>
-            </a:r>
-            <a:r>
-              <a:rPr lang="en-US" err="1">
-                <a:solidFill>
-                  <a:srgbClr val="000000"/>
-                </a:solidFill>
-              </a:rPr>
-              <a:t>Méthodo</a:t>
-            </a:r>
-            <a:endParaRPr lang="en-US"/>
-          </a:p>
-          <a:p>
-            <a:pPr algn="l"/>
-            <a:r>
-              <a:rPr lang="en-US">
-                <a:solidFill>
-                  <a:srgbClr val="000000"/>
-                </a:solidFill>
-              </a:rPr>
-              <a:t>Julien: </a:t>
-            </a:r>
-            <a:r>
-              <a:rPr lang="en-US" err="1">
-                <a:solidFill>
-                  <a:srgbClr val="000000"/>
-                </a:solidFill>
-              </a:rPr>
-              <a:t>Contexte</a:t>
-            </a:r>
-            <a:r>
-              <a:rPr lang="en-US">
-                <a:solidFill>
-                  <a:srgbClr val="000000"/>
-                </a:solidFill>
-              </a:rPr>
-              <a:t>, </a:t>
-            </a:r>
-            <a:r>
-              <a:rPr lang="en-US" err="1">
-                <a:solidFill>
-                  <a:srgbClr val="000000"/>
-                </a:solidFill>
-              </a:rPr>
-              <a:t>Enjeux</a:t>
-            </a:r>
-            <a:endParaRPr lang="en-US"/>
-          </a:p>
-          <a:p>
-            <a:pPr algn="l"/>
-            <a:r>
-              <a:rPr lang="en-US">
-                <a:solidFill>
-                  <a:srgbClr val="000000"/>
-                </a:solidFill>
-              </a:rPr>
-              <a:t>Mohamed: Technique (LLM, RaG)</a:t>
-            </a:r>
-            <a:endParaRPr lang="en-US"/>
-          </a:p>
-          <a:p>
-            <a:pPr algn="l"/>
-            <a:r>
-              <a:rPr lang="en-US">
-                <a:solidFill>
-                  <a:srgbClr val="000000"/>
-                </a:solidFill>
-              </a:rPr>
-              <a:t>Andraanick: Technique (Cluster Télécom)</a:t>
-            </a:r>
-            <a:endParaRPr lang="en-US"/>
-          </a:p>
-          <a:p>
-            <a:pPr algn="l"/>
-            <a:r>
-              <a:rPr lang="en-US">
-                <a:solidFill>
-                  <a:srgbClr val="000000"/>
-                </a:solidFill>
-              </a:rPr>
-              <a:t> </a:t>
-            </a:r>
-            <a:endParaRPr lang="en-US"/>
-          </a:p>
-          <a:p>
-            <a:pPr algn="l"/>
-            <a:r>
-              <a:rPr lang="en-US">
-                <a:solidFill>
-                  <a:srgbClr val="000000"/>
-                </a:solidFill>
-              </a:rPr>
-              <a:t>1minute 30 par slide x 10 slides = 15 minutes</a:t>
-            </a:r>
-            <a:endParaRPr lang="en-US"/>
-          </a:p>
-          <a:p>
-            <a:pPr algn="l"/>
-            <a:r>
-              <a:rPr lang="en-US">
-                <a:solidFill>
-                  <a:srgbClr val="000000"/>
-                </a:solidFill>
-              </a:rPr>
-              <a:t>Chaque personne présente 2 slides.</a:t>
-            </a:r>
-            <a:endParaRPr lang="en-US"/>
-          </a:p>
-          <a:p>
-            <a:endParaRPr lang="en-US">
+            <a:endParaRPr lang="en-US" dirty="0">
               <a:solidFill>
                 <a:srgbClr val="000000"/>
               </a:solidFill>
@@ -1394,6 +720,100 @@
 </p:notes>
 </file>
 
+<file path=ppt/notesSlides/notesSlide11.xml><?xml version="1.0" encoding="utf-8"?>
+<p:notes xmlns:a="http://schemas.openxmlformats.org/drawingml/2006/main" xmlns:r="http://schemas.openxmlformats.org/officeDocument/2006/relationships" xmlns:p="http://schemas.openxmlformats.org/presentationml/2006/main">
+  <p:cSld>
+    <p:spTree>
+      <p:nvGrpSpPr>
+        <p:cNvPr id="1" name="">
+          <a:extLst>
+            <a:ext uri="{FF2B5EF4-FFF2-40B4-BE49-F238E27FC236}">
+              <a16:creationId xmlns:a16="http://schemas.microsoft.com/office/drawing/2014/main" id="{D36105C8-2C7C-1D15-65F2-8FA7CE7C5FFE}"/>
+            </a:ext>
+          </a:extLst>
+        </p:cNvPr>
+        <p:cNvGrpSpPr/>
+        <p:nvPr/>
+      </p:nvGrpSpPr>
+      <p:grpSpPr>
+        <a:xfrm>
+          <a:off x="0" y="0"/>
+          <a:ext cx="0" cy="0"/>
+          <a:chOff x="0" y="0"/>
+          <a:chExt cx="0" cy="0"/>
+        </a:xfrm>
+      </p:grpSpPr>
+      <p:sp>
+        <p:nvSpPr>
+          <p:cNvPr id="2" name="Espace réservé de l'image des diapositives 1">
+            <a:extLst>
+              <a:ext uri="{FF2B5EF4-FFF2-40B4-BE49-F238E27FC236}">
+                <a16:creationId xmlns:a16="http://schemas.microsoft.com/office/drawing/2014/main" id="{50368286-E00C-F067-8CFF-53ED76C8BA88}"/>
+              </a:ext>
+            </a:extLst>
+          </p:cNvPr>
+          <p:cNvSpPr>
+            <a:spLocks noGrp="1" noRot="1" noChangeAspect="1"/>
+          </p:cNvSpPr>
+          <p:nvPr>
+            <p:ph type="sldImg"/>
+          </p:nvPr>
+        </p:nvSpPr>
+        <p:spPr>
+          <a:xfrm>
+            <a:off x="381000" y="685800"/>
+            <a:ext cx="6096000" cy="3429000"/>
+          </a:xfrm>
+        </p:spPr>
+      </p:sp>
+      <p:sp>
+        <p:nvSpPr>
+          <p:cNvPr id="3" name="Espace réservé des notes 2">
+            <a:extLst>
+              <a:ext uri="{FF2B5EF4-FFF2-40B4-BE49-F238E27FC236}">
+                <a16:creationId xmlns:a16="http://schemas.microsoft.com/office/drawing/2014/main" id="{CD43A11D-1382-F0DA-C610-2E3E73813E1A}"/>
+              </a:ext>
+            </a:extLst>
+          </p:cNvPr>
+          <p:cNvSpPr>
+            <a:spLocks noGrp="1"/>
+          </p:cNvSpPr>
+          <p:nvPr>
+            <p:ph type="body" idx="1"/>
+          </p:nvPr>
+        </p:nvSpPr>
+        <p:spPr/>
+        <p:txBody>
+          <a:bodyPr/>
+          <a:lstStyle/>
+          <a:p>
+            <a:r>
+              <a:rPr lang="en-US">
+                <a:solidFill>
+                  <a:srgbClr val="000000"/>
+                </a:solidFill>
+                <a:latin typeface="Calibri"/>
+                <a:ea typeface="Calibri"/>
+                <a:cs typeface="Calibri"/>
+              </a:rPr>
+              <a:t>Julien – 1 minute 30</a:t>
+            </a:r>
+          </a:p>
+        </p:txBody>
+      </p:sp>
+    </p:spTree>
+    <p:extLst>
+      <p:ext uri="{BB962C8B-B14F-4D97-AF65-F5344CB8AC3E}">
+        <p14:creationId xmlns:p14="http://schemas.microsoft.com/office/powerpoint/2010/main" val="354785848"/>
+      </p:ext>
+    </p:extLst>
+  </p:cSld>
+  <p:clrMapOvr>
+    <a:masterClrMapping/>
+  </p:clrMapOvr>
+</p:notes>
+</file>
+
 <file path=ppt/notesSlides/notesSlide2.xml><?xml version="1.0" encoding="utf-8"?>
 <p:notes xmlns:a="http://schemas.openxmlformats.org/drawingml/2006/main" xmlns:r="http://schemas.openxmlformats.org/officeDocument/2006/relationships" xmlns:p="http://schemas.openxmlformats.org/presentationml/2006/main">
   <p:cSld>
@@ -1444,7 +864,7 @@
           <a:lstStyle/>
           <a:p>
             <a:r>
-              <a:rPr lang="en-US">
+              <a:rPr lang="en-US" dirty="0">
                 <a:solidFill>
                   <a:srgbClr val="000000"/>
                 </a:solidFill>
@@ -1452,7 +872,7 @@
                 <a:ea typeface="Calibri"/>
                 <a:cs typeface="Calibri"/>
               </a:rPr>
-              <a:t>Julien – 1 minute 30</a:t>
+              <a:t>JULIEN</a:t>
             </a:r>
           </a:p>
         </p:txBody>
@@ -1538,7 +958,7 @@
           <a:lstStyle/>
           <a:p>
             <a:r>
-              <a:rPr lang="en-US">
+              <a:rPr lang="en-US" dirty="0">
                 <a:solidFill>
                   <a:srgbClr val="000000"/>
                 </a:solidFill>
@@ -1546,7 +966,7 @@
                 <a:ea typeface="Calibri"/>
                 <a:cs typeface="Calibri"/>
               </a:rPr>
-              <a:t>Julien – 1 minute 30</a:t>
+              <a:t>YASSINE</a:t>
             </a:r>
           </a:p>
         </p:txBody>
@@ -1632,7 +1052,7 @@
           <a:lstStyle/>
           <a:p>
             <a:r>
-              <a:rPr lang="en-US">
+              <a:rPr lang="en-US" dirty="0">
                 <a:solidFill>
                   <a:srgbClr val="000000"/>
                 </a:solidFill>
@@ -1640,7 +1060,7 @@
                 <a:ea typeface="Calibri"/>
                 <a:cs typeface="Calibri"/>
               </a:rPr>
-              <a:t>Julien – 1 minute 30</a:t>
+              <a:t>YASSINE</a:t>
             </a:r>
           </a:p>
         </p:txBody>
@@ -1726,7 +1146,7 @@
           <a:lstStyle/>
           <a:p>
             <a:r>
-              <a:rPr lang="en-US">
+              <a:rPr lang="en-US" dirty="0">
                 <a:solidFill>
                   <a:srgbClr val="000000"/>
                 </a:solidFill>
@@ -1734,7 +1154,7 @@
                 <a:ea typeface="Calibri"/>
                 <a:cs typeface="Calibri"/>
               </a:rPr>
-              <a:t>Julien – 1 minute 30</a:t>
+              <a:t>YASSINE</a:t>
             </a:r>
           </a:p>
         </p:txBody>
@@ -1820,7 +1240,7 @@
           <a:lstStyle/>
           <a:p>
             <a:r>
-              <a:rPr lang="en-US">
+              <a:rPr lang="en-US" dirty="0">
                 <a:solidFill>
                   <a:srgbClr val="000000"/>
                 </a:solidFill>
@@ -1828,7 +1248,7 @@
                 <a:ea typeface="Calibri"/>
                 <a:cs typeface="Calibri"/>
               </a:rPr>
-              <a:t>Julien – 1 minute 30</a:t>
+              <a:t>SARA</a:t>
             </a:r>
           </a:p>
         </p:txBody>
@@ -1914,7 +1334,7 @@
           <a:lstStyle/>
           <a:p>
             <a:r>
-              <a:rPr lang="en-US">
+              <a:rPr lang="en-US" dirty="0">
                 <a:solidFill>
                   <a:srgbClr val="000000"/>
                 </a:solidFill>
@@ -1922,7 +1342,7 @@
                 <a:ea typeface="Calibri"/>
                 <a:cs typeface="Calibri"/>
               </a:rPr>
-              <a:t>Julien – 1 minute 30</a:t>
+              <a:t>SARA</a:t>
             </a:r>
           </a:p>
         </p:txBody>
@@ -2008,7 +1428,7 @@
           <a:lstStyle/>
           <a:p>
             <a:r>
-              <a:rPr lang="en-US">
+              <a:rPr lang="en-US" dirty="0">
                 <a:solidFill>
                   <a:srgbClr val="000000"/>
                 </a:solidFill>
@@ -2016,7 +1436,7 @@
                 <a:ea typeface="Calibri"/>
                 <a:cs typeface="Calibri"/>
               </a:rPr>
-              <a:t>Julien – 1 minute 30</a:t>
+              <a:t>AMINE</a:t>
             </a:r>
           </a:p>
         </p:txBody>
@@ -2102,7 +1522,7 @@
           <a:lstStyle/>
           <a:p>
             <a:r>
-              <a:rPr lang="en-US">
+              <a:rPr lang="en-US" dirty="0">
                 <a:solidFill>
                   <a:srgbClr val="000000"/>
                 </a:solidFill>
@@ -2729,7 +2149,7 @@
           </a:ln>
           <a:extLst>
             <a:ext uri="{C572A759-6A51-4108-AA02-DFA0A04FC94B}">
-              <ma14:wrappingTextBoxFlag xmlns:m="http://schemas.openxmlformats.org/officeDocument/2006/math" xmlns:a14="http://schemas.microsoft.com/office/drawing/2010/main" xmlns:ma14="http://schemas.microsoft.com/office/mac/drawingml/2011/main" xmlns="" val="1"/>
+              <ma14:wrappingTextBoxFlag xmlns="" xmlns:ma14="http://schemas.microsoft.com/office/mac/drawingml/2011/main" xmlns:a14="http://schemas.microsoft.com/office/drawing/2010/main" xmlns:m="http://schemas.openxmlformats.org/officeDocument/2006/math" val="1"/>
             </a:ext>
           </a:extLst>
         </p:spPr>
@@ -2768,7 +2188,7 @@
           </a:ln>
           <a:extLst>
             <a:ext uri="{C572A759-6A51-4108-AA02-DFA0A04FC94B}">
-              <ma14:wrappingTextBoxFlag xmlns:m="http://schemas.openxmlformats.org/officeDocument/2006/math" xmlns:a14="http://schemas.microsoft.com/office/drawing/2010/main" xmlns:ma14="http://schemas.microsoft.com/office/mac/drawingml/2011/main" xmlns="" val="1"/>
+              <ma14:wrappingTextBoxFlag xmlns="" xmlns:ma14="http://schemas.microsoft.com/office/mac/drawingml/2011/main" xmlns:a14="http://schemas.microsoft.com/office/drawing/2010/main" xmlns:m="http://schemas.openxmlformats.org/officeDocument/2006/math" val="1"/>
             </a:ext>
           </a:extLst>
         </p:spPr>
@@ -3661,7 +3081,7 @@
           </a:ln>
           <a:extLst>
             <a:ext uri="{C572A759-6A51-4108-AA02-DFA0A04FC94B}">
-              <ma14:wrappingTextBoxFlag xmlns:m="http://schemas.openxmlformats.org/officeDocument/2006/math" xmlns:a14="http://schemas.microsoft.com/office/drawing/2010/main" xmlns:ma14="http://schemas.microsoft.com/office/mac/drawingml/2011/main" xmlns="" val="1"/>
+              <ma14:wrappingTextBoxFlag xmlns="" xmlns:ma14="http://schemas.microsoft.com/office/mac/drawingml/2011/main" xmlns:a14="http://schemas.microsoft.com/office/drawing/2010/main" xmlns:m="http://schemas.openxmlformats.org/officeDocument/2006/math" val="1"/>
             </a:ext>
           </a:extLst>
         </p:spPr>
@@ -4106,7 +3526,7 @@
           </a:ln>
           <a:extLst>
             <a:ext uri="{C572A759-6A51-4108-AA02-DFA0A04FC94B}">
-              <ma14:wrappingTextBoxFlag xmlns:m="http://schemas.openxmlformats.org/officeDocument/2006/math" xmlns:a14="http://schemas.microsoft.com/office/drawing/2010/main" xmlns:ma14="http://schemas.microsoft.com/office/mac/drawingml/2011/main" xmlns="" val="1"/>
+              <ma14:wrappingTextBoxFlag xmlns="" xmlns:ma14="http://schemas.microsoft.com/office/mac/drawingml/2011/main" xmlns:a14="http://schemas.microsoft.com/office/drawing/2010/main" xmlns:m="http://schemas.openxmlformats.org/officeDocument/2006/math" val="1"/>
             </a:ext>
           </a:extLst>
         </p:spPr>
@@ -4360,7 +3780,21 @@
                 <a:latin typeface="Poppins"/>
                 <a:cs typeface="Poppins"/>
               </a:rPr>
-              <a:t>Le home-server de Julien:</a:t>
+              <a:t>Le home-server de Julien (</a:t>
+            </a:r>
+            <a:r>
+              <a:rPr lang="fr-FR" sz="6000" dirty="0" err="1">
+                <a:latin typeface="Poppins"/>
+                <a:cs typeface="Poppins"/>
+              </a:rPr>
+              <a:t>lafrance.io</a:t>
+            </a:r>
+            <a:r>
+              <a:rPr lang="fr-FR" sz="6000" dirty="0">
+                <a:latin typeface="Poppins"/>
+                <a:cs typeface="Poppins"/>
+              </a:rPr>
+              <a:t>) :</a:t>
             </a:r>
           </a:p>
           <a:p>
@@ -4456,7 +3890,7 @@
                 <a:latin typeface="Poppins"/>
                 <a:cs typeface="Poppins"/>
               </a:rPr>
-              <a:t> séparément (s3fast.llafrance.io)</a:t>
+              <a:t> séparément (s3fast.lafrance.io)</a:t>
             </a:r>
           </a:p>
           <a:p>
@@ -4576,7 +4010,7 @@
                 <a:latin typeface="Poppins"/>
                 <a:cs typeface="Poppins"/>
               </a:rPr>
-              <a:t> séparément (s3fast.llafrance.io)</a:t>
+              <a:t> séparément (s3fast.lafrance.io)</a:t>
             </a:r>
           </a:p>
           <a:p>
@@ -4605,6 +4039,481 @@
 </file>
 
 <file path=ppt/slides/slide11.xml><?xml version="1.0" encoding="utf-8"?>
+<p:sld xmlns:a="http://schemas.openxmlformats.org/drawingml/2006/main" xmlns:r="http://schemas.openxmlformats.org/officeDocument/2006/relationships" xmlns:p="http://schemas.openxmlformats.org/presentationml/2006/main">
+  <p:cSld>
+    <p:spTree>
+      <p:nvGrpSpPr>
+        <p:cNvPr id="1" name="">
+          <a:extLst>
+            <a:ext uri="{FF2B5EF4-FFF2-40B4-BE49-F238E27FC236}">
+              <a16:creationId xmlns:a16="http://schemas.microsoft.com/office/drawing/2014/main" id="{2834EBFD-2D9B-B255-46D8-27807298CAFC}"/>
+            </a:ext>
+          </a:extLst>
+        </p:cNvPr>
+        <p:cNvGrpSpPr/>
+        <p:nvPr/>
+      </p:nvGrpSpPr>
+      <p:grpSpPr>
+        <a:xfrm>
+          <a:off x="0" y="0"/>
+          <a:ext cx="0" cy="0"/>
+          <a:chOff x="0" y="0"/>
+          <a:chExt cx="0" cy="0"/>
+        </a:xfrm>
+      </p:grpSpPr>
+      <p:sp>
+        <p:nvSpPr>
+          <p:cNvPr id="59" name="Titre 4">
+            <a:extLst>
+              <a:ext uri="{FF2B5EF4-FFF2-40B4-BE49-F238E27FC236}">
+                <a16:creationId xmlns:a16="http://schemas.microsoft.com/office/drawing/2014/main" id="{A630CFDE-106E-794F-EF20-7B846A4B7F46}"/>
+              </a:ext>
+            </a:extLst>
+          </p:cNvPr>
+          <p:cNvSpPr txBox="1"/>
+          <p:nvPr/>
+        </p:nvSpPr>
+        <p:spPr>
+          <a:xfrm>
+            <a:off x="3167745" y="1087347"/>
+            <a:ext cx="21410219" cy="1525224"/>
+          </a:xfrm>
+          <a:prstGeom prst="rect">
+            <a:avLst/>
+          </a:prstGeom>
+          <a:ln w="12700">
+            <a:miter lim="400000"/>
+          </a:ln>
+          <a:extLst>
+            <a:ext uri="{C572A759-6A51-4108-AA02-DFA0A04FC94B}">
+              <ma14:wrappingTextBoxFlag xmlns="" xmlns:ma14="http://schemas.microsoft.com/office/mac/drawingml/2011/main" xmlns:a14="http://schemas.microsoft.com/office/drawing/2010/main" xmlns:m="http://schemas.openxmlformats.org/officeDocument/2006/math" val="1"/>
+            </a:ext>
+          </a:extLst>
+        </p:spPr>
+        <p:txBody>
+          <a:bodyPr lIns="50800" tIns="50800" rIns="50800" bIns="50800" anchor="b">
+            <a:noAutofit/>
+          </a:bodyPr>
+          <a:lstStyle>
+            <a:lvl1pPr defTabSz="2270580">
+              <a:lnSpc>
+                <a:spcPct val="80000"/>
+              </a:lnSpc>
+              <a:defRPr sz="9312" spc="-194">
+                <a:solidFill>
+                  <a:srgbClr val="000000"/>
+                </a:solidFill>
+                <a:latin typeface="Poppins"/>
+                <a:ea typeface="Poppins"/>
+                <a:cs typeface="Poppins"/>
+                <a:sym typeface="Poppins"/>
+              </a:defRPr>
+            </a:lvl1pPr>
+          </a:lstStyle>
+          <a:p>
+            <a:r>
+              <a:rPr lang="fr-FR" sz="9300" dirty="0"/>
+              <a:t>Nos liens</a:t>
+            </a:r>
+          </a:p>
+        </p:txBody>
+      </p:sp>
+      <p:grpSp>
+        <p:nvGrpSpPr>
+          <p:cNvPr id="63" name="Groupe 43">
+            <a:extLst>
+              <a:ext uri="{FF2B5EF4-FFF2-40B4-BE49-F238E27FC236}">
+                <a16:creationId xmlns:a16="http://schemas.microsoft.com/office/drawing/2014/main" id="{9471B9F5-CA6D-92E8-EB94-DA982CE051D8}"/>
+              </a:ext>
+            </a:extLst>
+          </p:cNvPr>
+          <p:cNvGrpSpPr/>
+          <p:nvPr/>
+        </p:nvGrpSpPr>
+        <p:grpSpPr>
+          <a:xfrm>
+            <a:off x="9209313" y="12705060"/>
+            <a:ext cx="15174687" cy="432925"/>
+            <a:chOff x="0" y="0"/>
+            <a:chExt cx="15174685" cy="432924"/>
+          </a:xfrm>
+        </p:grpSpPr>
+        <p:sp>
+          <p:nvSpPr>
+            <p:cNvPr id="60" name="Rectangle 44">
+              <a:extLst>
+                <a:ext uri="{FF2B5EF4-FFF2-40B4-BE49-F238E27FC236}">
+                  <a16:creationId xmlns:a16="http://schemas.microsoft.com/office/drawing/2014/main" id="{38CAD1B4-D701-CA91-4B48-EC26BE5E6FFE}"/>
+                </a:ext>
+              </a:extLst>
+            </p:cNvPr>
+            <p:cNvSpPr/>
+            <p:nvPr/>
+          </p:nvSpPr>
+          <p:spPr>
+            <a:xfrm>
+              <a:off x="0" y="-1"/>
+              <a:ext cx="5049480" cy="432926"/>
+            </a:xfrm>
+            <a:prstGeom prst="rect">
+              <a:avLst/>
+            </a:prstGeom>
+            <a:solidFill>
+              <a:srgbClr val="BF1238"/>
+            </a:solidFill>
+            <a:ln w="12700" cap="flat">
+              <a:noFill/>
+              <a:miter lim="400000"/>
+            </a:ln>
+            <a:effectLst/>
+          </p:spPr>
+          <p:txBody>
+            <a:bodyPr wrap="square" lIns="50800" tIns="50800" rIns="50800" bIns="50800" numCol="1" anchor="t">
+              <a:noAutofit/>
+            </a:bodyPr>
+            <a:lstStyle/>
+            <a:p>
+              <a:pPr defTabSz="914400">
+                <a:defRPr sz="1800">
+                  <a:solidFill>
+                    <a:srgbClr val="000000"/>
+                  </a:solidFill>
+                  <a:latin typeface="Arial"/>
+                  <a:ea typeface="Arial"/>
+                  <a:cs typeface="Arial"/>
+                  <a:sym typeface="Arial"/>
+                </a:defRPr>
+              </a:pPr>
+              <a:endParaRPr/>
+            </a:p>
+          </p:txBody>
+        </p:sp>
+        <p:sp>
+          <p:nvSpPr>
+            <p:cNvPr id="61" name="Rectangle 45">
+              <a:extLst>
+                <a:ext uri="{FF2B5EF4-FFF2-40B4-BE49-F238E27FC236}">
+                  <a16:creationId xmlns:a16="http://schemas.microsoft.com/office/drawing/2014/main" id="{DFB526AC-E634-9AEE-49C1-AA7D8B93B664}"/>
+                </a:ext>
+              </a:extLst>
+            </p:cNvPr>
+            <p:cNvSpPr/>
+            <p:nvPr/>
+          </p:nvSpPr>
+          <p:spPr>
+            <a:xfrm>
+              <a:off x="5062117" y="-1"/>
+              <a:ext cx="5049480" cy="432926"/>
+            </a:xfrm>
+            <a:prstGeom prst="rect">
+              <a:avLst/>
+            </a:prstGeom>
+            <a:solidFill>
+              <a:srgbClr val="000000"/>
+            </a:solidFill>
+            <a:ln w="12700" cap="flat">
+              <a:noFill/>
+              <a:miter lim="400000"/>
+            </a:ln>
+            <a:effectLst/>
+          </p:spPr>
+          <p:txBody>
+            <a:bodyPr wrap="square" lIns="50800" tIns="50800" rIns="50800" bIns="50800" numCol="1" anchor="t">
+              <a:noAutofit/>
+            </a:bodyPr>
+            <a:lstStyle/>
+            <a:p>
+              <a:pPr defTabSz="914400">
+                <a:defRPr sz="1800">
+                  <a:solidFill>
+                    <a:srgbClr val="000000"/>
+                  </a:solidFill>
+                  <a:latin typeface="Arial"/>
+                  <a:ea typeface="Arial"/>
+                  <a:cs typeface="Arial"/>
+                  <a:sym typeface="Arial"/>
+                </a:defRPr>
+              </a:pPr>
+              <a:endParaRPr/>
+            </a:p>
+          </p:txBody>
+        </p:sp>
+        <p:sp>
+          <p:nvSpPr>
+            <p:cNvPr id="62" name="Rectangle 46">
+              <a:extLst>
+                <a:ext uri="{FF2B5EF4-FFF2-40B4-BE49-F238E27FC236}">
+                  <a16:creationId xmlns:a16="http://schemas.microsoft.com/office/drawing/2014/main" id="{5C1211CA-FBCF-3FA1-6274-DA8EC5FF45B3}"/>
+                </a:ext>
+              </a:extLst>
+            </p:cNvPr>
+            <p:cNvSpPr/>
+            <p:nvPr/>
+          </p:nvSpPr>
+          <p:spPr>
+            <a:xfrm>
+              <a:off x="10125206" y="-1"/>
+              <a:ext cx="5049480" cy="432926"/>
+            </a:xfrm>
+            <a:prstGeom prst="rect">
+              <a:avLst/>
+            </a:prstGeom>
+            <a:solidFill>
+              <a:srgbClr val="6D5047"/>
+            </a:solidFill>
+            <a:ln w="12700" cap="flat">
+              <a:noFill/>
+              <a:miter lim="400000"/>
+            </a:ln>
+            <a:effectLst/>
+          </p:spPr>
+          <p:txBody>
+            <a:bodyPr wrap="square" lIns="50800" tIns="50800" rIns="50800" bIns="50800" numCol="1" anchor="t">
+              <a:noAutofit/>
+            </a:bodyPr>
+            <a:lstStyle/>
+            <a:p>
+              <a:pPr defTabSz="914400">
+                <a:defRPr sz="1800">
+                  <a:solidFill>
+                    <a:srgbClr val="000000"/>
+                  </a:solidFill>
+                  <a:latin typeface="Arial"/>
+                  <a:ea typeface="Arial"/>
+                  <a:cs typeface="Arial"/>
+                  <a:sym typeface="Arial"/>
+                </a:defRPr>
+              </a:pPr>
+              <a:endParaRPr/>
+            </a:p>
+          </p:txBody>
+        </p:sp>
+      </p:grpSp>
+      <p:sp>
+        <p:nvSpPr>
+          <p:cNvPr id="4" name="ZoneTexte 3">
+            <a:extLst>
+              <a:ext uri="{FF2B5EF4-FFF2-40B4-BE49-F238E27FC236}">
+                <a16:creationId xmlns:a16="http://schemas.microsoft.com/office/drawing/2014/main" id="{A7DF1C78-F8F7-0F47-E720-C129B88E535F}"/>
+              </a:ext>
+            </a:extLst>
+          </p:cNvPr>
+          <p:cNvSpPr txBox="1"/>
+          <p:nvPr/>
+        </p:nvSpPr>
+        <p:spPr>
+          <a:xfrm>
+            <a:off x="3167745" y="3226218"/>
+            <a:ext cx="19574268" cy="5847755"/>
+          </a:xfrm>
+          <a:prstGeom prst="rect">
+            <a:avLst/>
+          </a:prstGeom>
+          <a:noFill/>
+          <a:ln w="12700" cap="flat">
+            <a:noFill/>
+            <a:miter lim="400000"/>
+          </a:ln>
+          <a:effectLst/>
+          <a:sp3d/>
+        </p:spPr>
+        <p:style>
+          <a:lnRef idx="0">
+            <a:scrgbClr r="0" g="0" b="0"/>
+          </a:lnRef>
+          <a:fillRef idx="0">
+            <a:scrgbClr r="0" g="0" b="0"/>
+          </a:fillRef>
+          <a:effectRef idx="0">
+            <a:scrgbClr r="0" g="0" b="0"/>
+          </a:effectRef>
+          <a:fontRef idx="none"/>
+        </p:style>
+        <p:txBody>
+          <a:bodyPr wrap="square">
+            <a:spAutoFit/>
+          </a:bodyPr>
+          <a:lstStyle/>
+          <a:p>
+            <a:r>
+              <a:rPr lang="fr-FR" sz="5400" b="1" dirty="0">
+                <a:latin typeface="Poppins"/>
+                <a:cs typeface="Poppins"/>
+              </a:rPr>
+              <a:t>PRD</a:t>
+            </a:r>
+          </a:p>
+          <a:p>
+            <a:endParaRPr lang="fr-FR" sz="4000" dirty="0">
+              <a:latin typeface="Poppins"/>
+              <a:cs typeface="Poppins"/>
+            </a:endParaRPr>
+          </a:p>
+          <a:p>
+            <a:r>
+              <a:rPr lang="fr-FR" sz="4000" b="1" dirty="0" err="1">
+                <a:latin typeface="Poppins"/>
+                <a:cs typeface="Poppins"/>
+              </a:rPr>
+              <a:t>Kestra</a:t>
+            </a:r>
+            <a:r>
+              <a:rPr lang="fr-FR" sz="4000" b="1" dirty="0">
+                <a:latin typeface="Poppins"/>
+                <a:cs typeface="Poppins"/>
+              </a:rPr>
+              <a:t>: </a:t>
+            </a:r>
+            <a:r>
+              <a:rPr lang="fr-FR" sz="4000" dirty="0">
+                <a:latin typeface="Poppins"/>
+                <a:cs typeface="Poppins"/>
+                <a:hlinkClick r:id="rId3"/>
+              </a:rPr>
+              <a:t>https://kestra713.lafrance.io</a:t>
+            </a:r>
+            <a:r>
+              <a:rPr lang="fr-FR" sz="4000" dirty="0">
+                <a:latin typeface="Poppins"/>
+                <a:cs typeface="Poppins"/>
+              </a:rPr>
+              <a:t> (705@lafrance.io/Proj@705)</a:t>
+            </a:r>
+          </a:p>
+          <a:p>
+            <a:endParaRPr lang="fr-FR" sz="4000" b="1" dirty="0">
+              <a:latin typeface="Poppins"/>
+              <a:cs typeface="Poppins"/>
+            </a:endParaRPr>
+          </a:p>
+          <a:p>
+            <a:r>
+              <a:rPr lang="fr-FR" sz="4000" b="1" dirty="0" err="1">
+                <a:latin typeface="Poppins"/>
+                <a:cs typeface="Poppins"/>
+              </a:rPr>
+              <a:t>Streamlit</a:t>
+            </a:r>
+            <a:r>
+              <a:rPr lang="fr-FR" sz="4000" b="1" dirty="0">
+                <a:latin typeface="Poppins"/>
+                <a:cs typeface="Poppins"/>
+              </a:rPr>
+              <a:t>: </a:t>
+            </a:r>
+            <a:r>
+              <a:rPr lang="fr-FR" sz="4000" dirty="0">
+                <a:latin typeface="Poppins"/>
+                <a:cs typeface="Poppins"/>
+                <a:hlinkClick r:id="rId4"/>
+              </a:rPr>
+              <a:t>https://webapp713.lafrance.io</a:t>
+            </a:r>
+            <a:endParaRPr lang="fr-FR" sz="4000" dirty="0">
+              <a:latin typeface="Poppins"/>
+              <a:cs typeface="Poppins"/>
+            </a:endParaRPr>
+          </a:p>
+          <a:p>
+            <a:endParaRPr lang="fr-FR" sz="4000" b="1" dirty="0">
+              <a:latin typeface="Poppins"/>
+              <a:cs typeface="Poppins"/>
+            </a:endParaRPr>
+          </a:p>
+          <a:p>
+            <a:r>
+              <a:rPr lang="fr-FR" sz="4000" b="1" dirty="0">
+                <a:latin typeface="Poppins"/>
+                <a:cs typeface="Poppins"/>
+              </a:rPr>
+              <a:t>API: </a:t>
+            </a:r>
+            <a:r>
+              <a:rPr lang="fr-FR" sz="4000" dirty="0">
+                <a:latin typeface="Poppins"/>
+                <a:cs typeface="Poppins"/>
+                <a:hlinkClick r:id="rId5"/>
+              </a:rPr>
+              <a:t>https://api713.lafrance.io/docs</a:t>
+            </a:r>
+            <a:endParaRPr lang="fr-FR" sz="4000" dirty="0">
+              <a:latin typeface="Poppins"/>
+              <a:cs typeface="Poppins"/>
+            </a:endParaRPr>
+          </a:p>
+          <a:p>
+            <a:endParaRPr lang="fr-FR" sz="4000" dirty="0">
+              <a:latin typeface="Poppins"/>
+              <a:cs typeface="Poppins"/>
+            </a:endParaRPr>
+          </a:p>
+          <a:p>
+            <a:r>
+              <a:rPr lang="fr-FR" sz="4000" b="1" dirty="0" err="1">
+                <a:latin typeface="Poppins"/>
+                <a:cs typeface="Poppins"/>
+              </a:rPr>
+              <a:t>Elastic</a:t>
+            </a:r>
+            <a:r>
+              <a:rPr lang="fr-FR" sz="4000" b="1" dirty="0">
+                <a:latin typeface="Poppins"/>
+                <a:cs typeface="Poppins"/>
+              </a:rPr>
+              <a:t>/</a:t>
+            </a:r>
+            <a:r>
+              <a:rPr lang="fr-FR" sz="4000" b="1" dirty="0" err="1">
+                <a:latin typeface="Poppins"/>
+                <a:cs typeface="Poppins"/>
+              </a:rPr>
+              <a:t>Kibana</a:t>
+            </a:r>
+            <a:r>
+              <a:rPr lang="fr-FR" sz="4000" b="1" dirty="0">
+                <a:latin typeface="Poppins"/>
+                <a:cs typeface="Poppins"/>
+              </a:rPr>
+              <a:t>: </a:t>
+            </a:r>
+            <a:r>
+              <a:rPr lang="fr-FR" sz="4000" dirty="0">
+                <a:latin typeface="Poppins"/>
+                <a:cs typeface="Poppins"/>
+                <a:hlinkClick r:id="rId6"/>
+              </a:rPr>
+              <a:t>https://kibana713.lafrance.</a:t>
+            </a:r>
+            <a:r>
+              <a:rPr lang="fr-FR" sz="4000" dirty="0">
+                <a:latin typeface="Poppins"/>
+                <a:cs typeface="Poppins"/>
+                <a:hlinkClick r:id="rId6"/>
+              </a:rPr>
+              <a:t>io</a:t>
+            </a:r>
+            <a:endParaRPr lang="fr-FR" sz="4000" dirty="0">
+              <a:latin typeface="Poppins"/>
+              <a:cs typeface="Poppins"/>
+            </a:endParaRPr>
+          </a:p>
+        </p:txBody>
+      </p:sp>
+    </p:spTree>
+    <p:extLst>
+      <p:ext uri="{BB962C8B-B14F-4D97-AF65-F5344CB8AC3E}">
+        <p14:creationId xmlns:p14="http://schemas.microsoft.com/office/powerpoint/2010/main" val="1786915383"/>
+      </p:ext>
+    </p:extLst>
+  </p:cSld>
+  <p:clrMapOvr>
+    <a:masterClrMapping/>
+  </p:clrMapOvr>
+  <p:transition spd="med"/>
+</p:sld>
+</file>
+
+<file path=ppt/slides/slide12.xml><?xml version="1.0" encoding="utf-8"?>
 <p:sld xmlns:a="http://schemas.openxmlformats.org/drawingml/2006/main" xmlns:r="http://schemas.openxmlformats.org/officeDocument/2006/relationships" xmlns:p="http://schemas.openxmlformats.org/presentationml/2006/main">
   <p:cSld>
     <p:spTree>
@@ -4667,7 +4576,7 @@
           </a:ln>
           <a:extLst>
             <a:ext uri="{C572A759-6A51-4108-AA02-DFA0A04FC94B}">
-              <ma14:wrappingTextBoxFlag xmlns:m="http://schemas.openxmlformats.org/officeDocument/2006/math" xmlns:a14="http://schemas.microsoft.com/office/drawing/2010/main" xmlns:ma14="http://schemas.microsoft.com/office/mac/drawingml/2011/main" xmlns="" val="1"/>
+              <ma14:wrappingTextBoxFlag xmlns="" xmlns:ma14="http://schemas.microsoft.com/office/mac/drawingml/2011/main" xmlns:a14="http://schemas.microsoft.com/office/drawing/2010/main" xmlns:m="http://schemas.openxmlformats.org/officeDocument/2006/math" val="1"/>
             </a:ext>
           </a:extLst>
         </p:spPr>
@@ -4743,7 +4652,7 @@
           </a:ln>
           <a:extLst>
             <a:ext uri="{C572A759-6A51-4108-AA02-DFA0A04FC94B}">
-              <ma14:wrappingTextBoxFlag xmlns:m="http://schemas.openxmlformats.org/officeDocument/2006/math" xmlns:a14="http://schemas.microsoft.com/office/drawing/2010/main" xmlns:ma14="http://schemas.microsoft.com/office/mac/drawingml/2011/main" xmlns="" val="1"/>
+              <ma14:wrappingTextBoxFlag xmlns="" xmlns:ma14="http://schemas.microsoft.com/office/mac/drawingml/2011/main" xmlns:a14="http://schemas.microsoft.com/office/drawing/2010/main" xmlns:m="http://schemas.openxmlformats.org/officeDocument/2006/math" val="1"/>
             </a:ext>
           </a:extLst>
         </p:spPr>
@@ -5300,37 +5209,7 @@
                 <a:latin typeface="Poppins"/>
                 <a:cs typeface="Poppins"/>
               </a:rPr>
-              <a:t> (Dev: </a:t>
-            </a:r>
-            <a:r>
-              <a:rPr lang="fr-FR" sz="3300" b="1" dirty="0" err="1">
-                <a:latin typeface="Poppins"/>
-                <a:cs typeface="Poppins"/>
-                <a:hlinkClick r:id="rId4"/>
-              </a:rPr>
-              <a:t>kestra.lafrance.io</a:t>
-            </a:r>
-            <a:r>
-              <a:rPr lang="fr-FR" sz="3300" b="1" dirty="0">
-                <a:latin typeface="Poppins"/>
-                <a:cs typeface="Poppins"/>
-              </a:rPr>
-              <a:t>, PRD: </a:t>
-            </a:r>
-            <a:r>
-              <a:rPr lang="fr-FR" sz="3300" b="1" dirty="0">
-                <a:latin typeface="Poppins"/>
-                <a:cs typeface="Poppins"/>
-                <a:hlinkClick r:id="rId5"/>
-              </a:rPr>
-              <a:t>kestra713.lafrance.io</a:t>
-            </a:r>
-            <a:r>
-              <a:rPr lang="fr-FR" sz="3300" b="1" dirty="0">
-                <a:latin typeface="Poppins"/>
-                <a:cs typeface="Poppins"/>
-              </a:rPr>
-              <a:t>):</a:t>
+              <a:t>:</a:t>
             </a:r>
           </a:p>
           <a:p>
@@ -5438,7 +5317,7 @@
           </a:ln>
           <a:extLst>
             <a:ext uri="{C572A759-6A51-4108-AA02-DFA0A04FC94B}">
-              <ma14:wrappingTextBoxFlag xmlns:m="http://schemas.openxmlformats.org/officeDocument/2006/math" xmlns:a14="http://schemas.microsoft.com/office/drawing/2010/main" xmlns:ma14="http://schemas.microsoft.com/office/mac/drawingml/2011/main" xmlns="" val="1"/>
+              <ma14:wrappingTextBoxFlag xmlns="" xmlns:ma14="http://schemas.microsoft.com/office/mac/drawingml/2011/main" xmlns:a14="http://schemas.microsoft.com/office/drawing/2010/main" xmlns:m="http://schemas.openxmlformats.org/officeDocument/2006/math" val="1"/>
             </a:ext>
           </a:extLst>
         </p:spPr>
@@ -5693,7 +5572,7 @@
         <p:spPr>
           <a:xfrm>
             <a:off x="3106385" y="2980544"/>
-            <a:ext cx="20612597" cy="1446550"/>
+            <a:ext cx="20612597" cy="769441"/>
           </a:xfrm>
           <a:prstGeom prst="rect">
             <a:avLst/>
@@ -5732,12 +5611,6 @@
               <a:t>Notre modèle se base sur la couche Gold et est exécuté tous les 6h.  </a:t>
             </a:r>
           </a:p>
-          <a:p>
-            <a:r>
-              <a:rPr lang="fr-FR" sz="4400" dirty="0"/>
-              <a:t>C’est un modèle SARIMA(2,0,0)(2,1,0,24).</a:t>
-            </a:r>
-          </a:p>
         </p:txBody>
       </p:sp>
       <p:sp>
@@ -5755,7 +5628,7 @@
         <p:spPr>
           <a:xfrm>
             <a:off x="3167745" y="8565631"/>
-            <a:ext cx="21216255" cy="3262432"/>
+            <a:ext cx="21216255" cy="4924425"/>
           </a:xfrm>
           <a:prstGeom prst="rect">
             <a:avLst/>
@@ -5787,21 +5660,21 @@
           <a:lstStyle/>
           <a:p>
             <a:r>
-              <a:rPr lang="fr-FR" sz="4400" dirty="0">
+              <a:rPr lang="fr-FR" sz="4400" b="1" dirty="0">
                 <a:latin typeface="Poppins"/>
                 <a:cs typeface="Poppins"/>
               </a:rPr>
               <a:t>2 flows (DAG sur </a:t>
             </a:r>
             <a:r>
-              <a:rPr lang="fr-FR" sz="4400" dirty="0" err="1">
+              <a:rPr lang="fr-FR" sz="4400" b="1" dirty="0" err="1">
                 <a:latin typeface="Poppins"/>
                 <a:cs typeface="Poppins"/>
               </a:rPr>
               <a:t>Kestra</a:t>
             </a:r>
             <a:r>
-              <a:rPr lang="fr-FR" sz="4400" dirty="0">
+              <a:rPr lang="fr-FR" sz="4400" b="1" dirty="0">
                 <a:latin typeface="Poppins"/>
                 <a:cs typeface="Poppins"/>
               </a:rPr>
@@ -5829,23 +5702,7 @@
             </a:r>
             <a:r>
               <a:rPr lang="fr-FR" sz="4400" b="1" dirty="0"/>
-              <a:t>: Prévision des </a:t>
-            </a:r>
-            <a:r>
-              <a:rPr lang="fr-FR" sz="4400" b="1" dirty="0" err="1"/>
-              <a:t>next</a:t>
-            </a:r>
-            <a:r>
-              <a:rPr lang="fr-FR" sz="4400" b="1" dirty="0"/>
-              <a:t> 3 </a:t>
-            </a:r>
-            <a:r>
-              <a:rPr lang="fr-FR" sz="4400" b="1" dirty="0" err="1"/>
-              <a:t>days</a:t>
-            </a:r>
-            <a:r>
-              <a:rPr lang="fr-FR" sz="4400" b="1" dirty="0"/>
-              <a:t> tous les 6 heures</a:t>
+              <a:t>: Prévision des 3 prochains jours tous les 6 heures</a:t>
             </a:r>
           </a:p>
           <a:p>
@@ -5859,7 +5716,20 @@
             </a:r>
             <a:r>
               <a:rPr lang="fr-FR" sz="4400" b="1" dirty="0"/>
-              <a:t>: Entrainement de SARIMA toutes les semaines</a:t>
+              <a:t>: Entrainement de SARIMA toutes les semaines </a:t>
+            </a:r>
+          </a:p>
+          <a:p>
+            <a:endParaRPr lang="fr-FR" sz="2000" b="1" dirty="0"/>
+          </a:p>
+          <a:p>
+            <a:r>
+              <a:rPr lang="fr-FR" sz="4400" b="1" dirty="0"/>
+              <a:t>Compétition des modèles pour training: </a:t>
+            </a:r>
+            <a:r>
+              <a:rPr lang="fr-FR" sz="4400" dirty="0"/>
+              <a:t>On utilise plusieurs paramètres (p, d, q / P, D, Q) avec nos données changeantes pour entrainer le meilleur modèle.</a:t>
             </a:r>
           </a:p>
           <a:p>
@@ -5929,7 +5799,7 @@
           </a:ln>
           <a:extLst>
             <a:ext uri="{C572A759-6A51-4108-AA02-DFA0A04FC94B}">
-              <ma14:wrappingTextBoxFlag xmlns:m="http://schemas.openxmlformats.org/officeDocument/2006/math" xmlns:a14="http://schemas.microsoft.com/office/drawing/2010/main" xmlns:ma14="http://schemas.microsoft.com/office/mac/drawingml/2011/main" xmlns="" val="1"/>
+              <ma14:wrappingTextBoxFlag xmlns="" xmlns:ma14="http://schemas.microsoft.com/office/mac/drawingml/2011/main" xmlns:a14="http://schemas.microsoft.com/office/drawing/2010/main" xmlns:m="http://schemas.openxmlformats.org/officeDocument/2006/math" val="1"/>
             </a:ext>
           </a:extLst>
         </p:spPr>
@@ -5977,7 +5847,7 @@
         <p:spPr>
           <a:xfrm>
             <a:off x="2963624" y="2900387"/>
-            <a:ext cx="11999285" cy="8402300"/>
+            <a:ext cx="11999285" cy="7171194"/>
           </a:xfrm>
           <a:prstGeom prst="rect">
             <a:avLst/>
@@ -6040,20 +5910,6 @@
               <a:t>1. Performance des prédictions</a:t>
             </a:r>
             <a:endParaRPr lang="fr-FR" sz="3600" dirty="0"/>
-          </a:p>
-          <a:p>
-            <a:r>
-              <a:rPr lang="fr-FR" sz="3600" dirty="0"/>
-              <a:t>À chaque exécution, on évalue la </a:t>
-            </a:r>
-            <a:r>
-              <a:rPr lang="fr-FR" sz="3600" b="1" dirty="0"/>
-              <a:t>dernière prévision complète sur 72h</a:t>
-            </a:r>
-            <a:r>
-              <a:rPr lang="fr-FR" sz="3600" dirty="0"/>
-              <a:t>.</a:t>
-            </a:r>
           </a:p>
           <a:p>
             <a:r>
@@ -6414,7 +6270,7 @@
           </a:ln>
           <a:extLst>
             <a:ext uri="{C572A759-6A51-4108-AA02-DFA0A04FC94B}">
-              <ma14:wrappingTextBoxFlag xmlns:m="http://schemas.openxmlformats.org/officeDocument/2006/math" xmlns:a14="http://schemas.microsoft.com/office/drawing/2010/main" xmlns:ma14="http://schemas.microsoft.com/office/mac/drawingml/2011/main" xmlns="" val="1"/>
+              <ma14:wrappingTextBoxFlag xmlns="" xmlns:ma14="http://schemas.microsoft.com/office/mac/drawingml/2011/main" xmlns:a14="http://schemas.microsoft.com/office/drawing/2010/main" xmlns:m="http://schemas.openxmlformats.org/officeDocument/2006/math" val="1"/>
             </a:ext>
           </a:extLst>
         </p:spPr>
@@ -6896,7 +6752,7 @@
           </a:ln>
           <a:extLst>
             <a:ext uri="{C572A759-6A51-4108-AA02-DFA0A04FC94B}">
-              <ma14:wrappingTextBoxFlag xmlns:m="http://schemas.openxmlformats.org/officeDocument/2006/math" xmlns:a14="http://schemas.microsoft.com/office/drawing/2010/main" xmlns:ma14="http://schemas.microsoft.com/office/mac/drawingml/2011/main" xmlns="" val="1"/>
+              <ma14:wrappingTextBoxFlag xmlns="" xmlns:ma14="http://schemas.microsoft.com/office/mac/drawingml/2011/main" xmlns:a14="http://schemas.microsoft.com/office/drawing/2010/main" xmlns:m="http://schemas.openxmlformats.org/officeDocument/2006/math" val="1"/>
             </a:ext>
           </a:extLst>
         </p:spPr>
@@ -7458,8 +7314,8 @@
         </p:blipFill>
         <p:spPr>
           <a:xfrm>
-            <a:off x="17170398" y="0"/>
-            <a:ext cx="7213601" cy="3873164"/>
+            <a:off x="17170398" y="578014"/>
+            <a:ext cx="7213601" cy="3295150"/>
           </a:xfrm>
           <a:prstGeom prst="rect">
             <a:avLst/>
@@ -7564,7 +7420,7 @@
           </a:ln>
           <a:extLst>
             <a:ext uri="{C572A759-6A51-4108-AA02-DFA0A04FC94B}">
-              <ma14:wrappingTextBoxFlag xmlns:m="http://schemas.openxmlformats.org/officeDocument/2006/math" xmlns:a14="http://schemas.microsoft.com/office/drawing/2010/main" xmlns:ma14="http://schemas.microsoft.com/office/mac/drawingml/2011/main" xmlns="" val="1"/>
+              <ma14:wrappingTextBoxFlag xmlns="" xmlns:ma14="http://schemas.microsoft.com/office/mac/drawingml/2011/main" xmlns:a14="http://schemas.microsoft.com/office/drawing/2010/main" xmlns:m="http://schemas.openxmlformats.org/officeDocument/2006/math" val="1"/>
             </a:ext>
           </a:extLst>
         </p:spPr>
@@ -8014,7 +7870,7 @@
           </a:ln>
           <a:extLst>
             <a:ext uri="{C572A759-6A51-4108-AA02-DFA0A04FC94B}">
-              <ma14:wrappingTextBoxFlag xmlns:m="http://schemas.openxmlformats.org/officeDocument/2006/math" xmlns:a14="http://schemas.microsoft.com/office/drawing/2010/main" xmlns:ma14="http://schemas.microsoft.com/office/mac/drawingml/2011/main" xmlns="" val="1"/>
+              <ma14:wrappingTextBoxFlag xmlns="" xmlns:ma14="http://schemas.microsoft.com/office/mac/drawingml/2011/main" xmlns:a14="http://schemas.microsoft.com/office/drawing/2010/main" xmlns:m="http://schemas.openxmlformats.org/officeDocument/2006/math" val="1"/>
             </a:ext>
           </a:extLst>
         </p:spPr>
@@ -8233,7 +8089,7 @@
         <p:spPr>
           <a:xfrm>
             <a:off x="3167745" y="3814141"/>
-            <a:ext cx="14294345" cy="6863417"/>
+            <a:ext cx="14294345" cy="7540526"/>
           </a:xfrm>
           <a:prstGeom prst="rect">
             <a:avLst/>
@@ -8307,14 +8163,19 @@
             </a:r>
             <a:r>
               <a:rPr lang="fr-FR" sz="4400" dirty="0"/>
-              <a:t> quand on push en « prod », les flows sont automatiquement déployés sur la VM.</a:t>
-            </a:r>
-          </a:p>
-          <a:p>
+              <a:t> quand on push en « prod », les flows sont automatiquement déployés sur </a:t>
+            </a:r>
+            <a:r>
+              <a:rPr lang="fr-FR" sz="4400" dirty="0" err="1"/>
+              <a:t>Kestra</a:t>
+            </a:r>
             <a:r>
               <a:rPr lang="fr-FR" sz="4400" dirty="0"/>
-              <a:t>Fichier </a:t>
-            </a:r>
+              <a:t>.</a:t>
+            </a:r>
+          </a:p>
+          <a:p>
+            <a:endParaRPr lang="fr-FR" sz="4400" dirty="0"/>
           </a:p>
           <a:p>
             <a:endParaRPr lang="fr-FR" sz="4400" dirty="0"/>
@@ -8330,7 +8191,15 @@
             </a:r>
             <a:r>
               <a:rPr lang="fr-FR" sz="4400" dirty="0"/>
-              <a:t> Toutes les semaines, l’entraînement est relancé avec de nouvelles données glissantes afin d’améliorer le modèle.</a:t>
+              <a:t> Toutes les semaines, l’entraînement est relancé avec de </a:t>
+            </a:r>
+            <a:r>
+              <a:rPr lang="fr-FR" sz="4400" b="1" dirty="0"/>
+              <a:t>nouvelles données glissantes + test de plusieurs paramètres </a:t>
+            </a:r>
+            <a:r>
+              <a:rPr lang="fr-FR" sz="4400" dirty="0"/>
+              <a:t>candidats pour améliorer le modèle.</a:t>
             </a:r>
           </a:p>
         </p:txBody>
@@ -8433,7 +8302,7 @@
           </a:ln>
           <a:extLst>
             <a:ext uri="{C572A759-6A51-4108-AA02-DFA0A04FC94B}">
-              <ma14:wrappingTextBoxFlag xmlns:m="http://schemas.openxmlformats.org/officeDocument/2006/math" xmlns:a14="http://schemas.microsoft.com/office/drawing/2010/main" xmlns:ma14="http://schemas.microsoft.com/office/mac/drawingml/2011/main" xmlns="" val="1"/>
+              <ma14:wrappingTextBoxFlag xmlns="" xmlns:ma14="http://schemas.microsoft.com/office/mac/drawingml/2011/main" xmlns:a14="http://schemas.microsoft.com/office/drawing/2010/main" xmlns:m="http://schemas.openxmlformats.org/officeDocument/2006/math" val="1"/>
             </a:ext>
           </a:extLst>
         </p:spPr>
@@ -8466,177 +8335,6 @@
           </a:p>
         </p:txBody>
       </p:sp>
-      <p:grpSp>
-        <p:nvGrpSpPr>
-          <p:cNvPr id="63" name="Groupe 43">
-            <a:extLst>
-              <a:ext uri="{FF2B5EF4-FFF2-40B4-BE49-F238E27FC236}">
-                <a16:creationId xmlns:a16="http://schemas.microsoft.com/office/drawing/2014/main" id="{911B4223-7826-A7E6-20EF-D25C7F5472FB}"/>
-              </a:ext>
-            </a:extLst>
-          </p:cNvPr>
-          <p:cNvGrpSpPr/>
-          <p:nvPr/>
-        </p:nvGrpSpPr>
-        <p:grpSpPr>
-          <a:xfrm>
-            <a:off x="9209313" y="12921522"/>
-            <a:ext cx="15174687" cy="432925"/>
-            <a:chOff x="0" y="0"/>
-            <a:chExt cx="15174685" cy="432924"/>
-          </a:xfrm>
-        </p:grpSpPr>
-        <p:sp>
-          <p:nvSpPr>
-            <p:cNvPr id="60" name="Rectangle 44">
-              <a:extLst>
-                <a:ext uri="{FF2B5EF4-FFF2-40B4-BE49-F238E27FC236}">
-                  <a16:creationId xmlns:a16="http://schemas.microsoft.com/office/drawing/2014/main" id="{9087996D-F0F8-0C5A-6AB6-BF6DA990405A}"/>
-                </a:ext>
-              </a:extLst>
-            </p:cNvPr>
-            <p:cNvSpPr/>
-            <p:nvPr/>
-          </p:nvSpPr>
-          <p:spPr>
-            <a:xfrm>
-              <a:off x="0" y="-1"/>
-              <a:ext cx="5049480" cy="432926"/>
-            </a:xfrm>
-            <a:prstGeom prst="rect">
-              <a:avLst/>
-            </a:prstGeom>
-            <a:solidFill>
-              <a:srgbClr val="BF1238"/>
-            </a:solidFill>
-            <a:ln w="12700" cap="flat">
-              <a:noFill/>
-              <a:miter lim="400000"/>
-            </a:ln>
-            <a:effectLst/>
-          </p:spPr>
-          <p:txBody>
-            <a:bodyPr wrap="square" lIns="50800" tIns="50800" rIns="50800" bIns="50800" numCol="1" anchor="t">
-              <a:noAutofit/>
-            </a:bodyPr>
-            <a:lstStyle/>
-            <a:p>
-              <a:pPr defTabSz="914400">
-                <a:defRPr sz="1800">
-                  <a:solidFill>
-                    <a:srgbClr val="000000"/>
-                  </a:solidFill>
-                  <a:latin typeface="Arial"/>
-                  <a:ea typeface="Arial"/>
-                  <a:cs typeface="Arial"/>
-                  <a:sym typeface="Arial"/>
-                </a:defRPr>
-              </a:pPr>
-              <a:endParaRPr/>
-            </a:p>
-          </p:txBody>
-        </p:sp>
-        <p:sp>
-          <p:nvSpPr>
-            <p:cNvPr id="61" name="Rectangle 45">
-              <a:extLst>
-                <a:ext uri="{FF2B5EF4-FFF2-40B4-BE49-F238E27FC236}">
-                  <a16:creationId xmlns:a16="http://schemas.microsoft.com/office/drawing/2014/main" id="{8E60C534-7F5F-E276-F5C7-14D5CACD1F93}"/>
-                </a:ext>
-              </a:extLst>
-            </p:cNvPr>
-            <p:cNvSpPr/>
-            <p:nvPr/>
-          </p:nvSpPr>
-          <p:spPr>
-            <a:xfrm>
-              <a:off x="5062117" y="-1"/>
-              <a:ext cx="5049480" cy="432926"/>
-            </a:xfrm>
-            <a:prstGeom prst="rect">
-              <a:avLst/>
-            </a:prstGeom>
-            <a:solidFill>
-              <a:srgbClr val="000000"/>
-            </a:solidFill>
-            <a:ln w="12700" cap="flat">
-              <a:noFill/>
-              <a:miter lim="400000"/>
-            </a:ln>
-            <a:effectLst/>
-          </p:spPr>
-          <p:txBody>
-            <a:bodyPr wrap="square" lIns="50800" tIns="50800" rIns="50800" bIns="50800" numCol="1" anchor="t">
-              <a:noAutofit/>
-            </a:bodyPr>
-            <a:lstStyle/>
-            <a:p>
-              <a:pPr defTabSz="914400">
-                <a:defRPr sz="1800">
-                  <a:solidFill>
-                    <a:srgbClr val="000000"/>
-                  </a:solidFill>
-                  <a:latin typeface="Arial"/>
-                  <a:ea typeface="Arial"/>
-                  <a:cs typeface="Arial"/>
-                  <a:sym typeface="Arial"/>
-                </a:defRPr>
-              </a:pPr>
-              <a:endParaRPr/>
-            </a:p>
-          </p:txBody>
-        </p:sp>
-        <p:sp>
-          <p:nvSpPr>
-            <p:cNvPr id="62" name="Rectangle 46">
-              <a:extLst>
-                <a:ext uri="{FF2B5EF4-FFF2-40B4-BE49-F238E27FC236}">
-                  <a16:creationId xmlns:a16="http://schemas.microsoft.com/office/drawing/2014/main" id="{14B97C6A-AB44-EF97-9305-5A00CFC88FD3}"/>
-                </a:ext>
-              </a:extLst>
-            </p:cNvPr>
-            <p:cNvSpPr/>
-            <p:nvPr/>
-          </p:nvSpPr>
-          <p:spPr>
-            <a:xfrm>
-              <a:off x="10125206" y="-1"/>
-              <a:ext cx="5049480" cy="432926"/>
-            </a:xfrm>
-            <a:prstGeom prst="rect">
-              <a:avLst/>
-            </a:prstGeom>
-            <a:solidFill>
-              <a:srgbClr val="6D5047"/>
-            </a:solidFill>
-            <a:ln w="12700" cap="flat">
-              <a:noFill/>
-              <a:miter lim="400000"/>
-            </a:ln>
-            <a:effectLst/>
-          </p:spPr>
-          <p:txBody>
-            <a:bodyPr wrap="square" lIns="50800" tIns="50800" rIns="50800" bIns="50800" numCol="1" anchor="t">
-              <a:noAutofit/>
-            </a:bodyPr>
-            <a:lstStyle/>
-            <a:p>
-              <a:pPr defTabSz="914400">
-                <a:defRPr sz="1800">
-                  <a:solidFill>
-                    <a:srgbClr val="000000"/>
-                  </a:solidFill>
-                  <a:latin typeface="Arial"/>
-                  <a:ea typeface="Arial"/>
-                  <a:cs typeface="Arial"/>
-                  <a:sym typeface="Arial"/>
-                </a:defRPr>
-              </a:pPr>
-              <a:endParaRPr/>
-            </a:p>
-          </p:txBody>
-        </p:sp>
-      </p:grpSp>
       <p:sp>
         <p:nvSpPr>
           <p:cNvPr id="5" name="ZoneTexte 4">
@@ -8749,15 +8447,7 @@
                 <a:cs typeface="Poppins"/>
                 <a:hlinkClick r:id="rId3"/>
               </a:rPr>
-              <a:t>Lien </a:t>
-            </a:r>
-            <a:r>
-              <a:rPr lang="fr-FR" sz="4000" dirty="0" err="1">
-                <a:latin typeface="Poppins"/>
-                <a:cs typeface="Poppins"/>
-                <a:hlinkClick r:id="rId3"/>
-              </a:rPr>
-              <a:t>Kibana</a:t>
+              <a:t>Lien Kibana</a:t>
             </a:r>
             <a:endParaRPr lang="fr-FR" sz="4000" dirty="0">
               <a:latin typeface="Poppins"/>
@@ -8768,10 +8458,10 @@
       </p:sp>
       <p:pic>
         <p:nvPicPr>
-          <p:cNvPr id="7" name="Image 6" descr="Une image contenant capture d’écran, texte, diagramme, Tracé&#10;&#10;Le contenu généré par l’IA peut être incorrect.">
+          <p:cNvPr id="10" name="Image 9" descr="Une image contenant diagramme, capture d’écran, Tracé, conception&#10;&#10;Le contenu généré par l’IA peut être incorrect.">
             <a:extLst>
               <a:ext uri="{FF2B5EF4-FFF2-40B4-BE49-F238E27FC236}">
-                <a16:creationId xmlns:a16="http://schemas.microsoft.com/office/drawing/2014/main" id="{DA52ED5C-8DD7-4831-4D25-60E9601414BC}"/>
+                <a16:creationId xmlns:a16="http://schemas.microsoft.com/office/drawing/2014/main" id="{F8132B74-10FF-B2EB-AB48-D09CCEAD9F85}"/>
               </a:ext>
             </a:extLst>
           </p:cNvPr>
@@ -8794,8 +8484,8 @@
         </p:blipFill>
         <p:spPr>
           <a:xfrm>
-            <a:off x="5899880" y="4929535"/>
-            <a:ext cx="13421032" cy="7699118"/>
+            <a:off x="4599214" y="4636667"/>
+            <a:ext cx="16617041" cy="8906842"/>
           </a:xfrm>
           <a:prstGeom prst="rect">
             <a:avLst/>

</xml_diff>